<commit_message>
Fix remaining slide inconsistencies (fonts, colors, layout, labels)
Co-Authored-By: Claude Opus 5.5 <noreply@anthropic.com>
Claude-Session: https://claude.ai/code/session_01SSsgejUtt6m8TLeiHRQ79A
</commit_message>
<xml_diff>
--- a/out/41411005E_林俊緯_隨堂測驗1.pptx
+++ b/out/41411005E_林俊緯_隨堂測驗1.pptx
@@ -975,6 +975,170 @@
 </file>
 
 <file path=ppt/slides/slide1.xml><?xml version="1.0" encoding="utf-8"?>
+<p:sld xmlns:a="http://schemas.openxmlformats.org/drawingml/2006/main" xmlns:p="http://schemas.openxmlformats.org/presentationml/2006/main" xmlns:r="http://schemas.openxmlformats.org/officeDocument/2006/relationships">
+  <p:cSld>
+    <p:spTree>
+      <p:nvGrpSpPr>
+        <p:cNvPr id="1" name=""/>
+        <p:cNvGrpSpPr/>
+        <p:nvPr/>
+      </p:nvGrpSpPr>
+      <p:grpSpPr/>
+      <p:sp>
+        <p:nvSpPr>
+          <p:cNvPr id="2" name="Shape 0"/>
+          <p:cNvSpPr/>
+          <p:nvPr/>
+        </p:nvSpPr>
+        <p:spPr>
+          <a:xfrm>
+            <a:off x="0" y="0"/>
+            <a:ext cx="12188952" cy="6858000"/>
+          </a:xfrm>
+          <a:prstGeom prst="rect">
+            <a:avLst/>
+          </a:prstGeom>
+          <a:solidFill>
+            <a:srgbClr val="FFFFFF"/>
+          </a:solidFill>
+          <a:ln/>
+        </p:spPr>
+        <p:txBody>
+          <a:bodyPr/>
+          <a:p/>
+        </p:txBody>
+      </p:sp>
+      <p:sp>
+        <p:nvSpPr>
+          <p:cNvPr id="3" name="TextBox 2"/>
+          <p:cNvSpPr txBox="1"/>
+          <p:nvPr/>
+        </p:nvSpPr>
+        <p:spPr>
+          <a:xfrm>
+            <a:off x="914400" y="1828800"/>
+            <a:ext cx="10363200" cy="3200400"/>
+          </a:xfrm>
+          <a:prstGeom prst="rect">
+            <a:avLst/>
+          </a:prstGeom>
+          <a:noFill/>
+        </p:spPr>
+        <p:txBody>
+          <a:bodyPr wrap="square">
+            <a:spAutoFit/>
+          </a:bodyPr>
+          <a:lstStyle/>
+          <a:p>
+            <a:pPr algn="ctr">
+              <a:spcAft>
+                <a:spcPts val="1200"/>
+              </a:spcAft>
+            </a:pPr>
+            <a:r>
+              <a:rPr sz="3600" b="1">
+                <a:solidFill>
+                  <a:srgbClr val="21295C"/>
+                </a:solidFill>
+                <a:latin typeface="Cambria"/>
+              </a:rPr>
+              <a:t>1151科學教育與傳播的未來： AI理論與實踐</a:t>
+            </a:r>
+          </a:p>
+          <a:p>
+            <a:pPr algn="ctr">
+              <a:spcAft>
+                <a:spcPts val="1200"/>
+              </a:spcAft>
+            </a:pPr>
+            <a:r>
+              <a:rPr sz="2800" b="0">
+                <a:solidFill>
+                  <a:srgbClr val="1B2430"/>
+                </a:solidFill>
+                <a:latin typeface="Calibri"/>
+              </a:rPr>
+              <a:t>隨堂測驗1 instruction in class exam</a:t>
+            </a:r>
+          </a:p>
+          <a:p>
+            <a:pPr algn="ctr">
+              <a:spcAft>
+                <a:spcPts val="1200"/>
+              </a:spcAft>
+            </a:pPr>
+            <a:r>
+              <a:rPr sz="2400" b="0">
+                <a:solidFill>
+                  <a:srgbClr val="1B2430"/>
+                </a:solidFill>
+                <a:latin typeface="Calibri"/>
+              </a:rPr>
+              <a:t>學號：41411005E</a:t>
+            </a:r>
+          </a:p>
+          <a:p>
+            <a:pPr algn="ctr">
+              <a:spcAft>
+                <a:spcPts val="1200"/>
+              </a:spcAft>
+            </a:pPr>
+            <a:r>
+              <a:rPr sz="2400" b="0">
+                <a:solidFill>
+                  <a:srgbClr val="1B2430"/>
+                </a:solidFill>
+                <a:latin typeface="Calibri"/>
+              </a:rPr>
+              <a:t>姓名：林俊緯</a:t>
+            </a:r>
+          </a:p>
+        </p:txBody>
+      </p:sp>
+      <p:sp>
+        <p:nvSpPr>
+          <p:cNvPr id="4" name="TextBox 3"/>
+          <p:cNvSpPr txBox="1"/>
+          <p:nvPr/>
+        </p:nvSpPr>
+        <p:spPr>
+          <a:xfrm>
+            <a:off x="10911840" y="6263640"/>
+            <a:ext cx="914400" cy="411480"/>
+          </a:xfrm>
+          <a:prstGeom prst="rect">
+            <a:avLst/>
+          </a:prstGeom>
+          <a:noFill/>
+        </p:spPr>
+        <p:txBody>
+          <a:bodyPr wrap="none">
+            <a:spAutoFit/>
+          </a:bodyPr>
+          <a:lstStyle/>
+          <a:p>
+            <a:pPr algn="r"/>
+            <a:r>
+              <a:rPr sz="1800">
+                <a:solidFill>
+                  <a:srgbClr val="5A6B78"/>
+                </a:solidFill>
+                <a:latin typeface="Calibri"/>
+              </a:rPr>
+              <a:t>1</a:t>
+            </a:r>
+          </a:p>
+        </p:txBody>
+      </p:sp>
+    </p:spTree>
+  </p:cSld>
+  <p:clrMapOvr>
+    <a:masterClrMapping/>
+  </p:clrMapOvr>
+</p:sld>
+</file>
+
+<file path=ppt/slides/slide2.xml><?xml version="1.0" encoding="utf-8"?>
 <p:sld xmlns:a="http://schemas.openxmlformats.org/drawingml/2006/main" xmlns:r="http://schemas.openxmlformats.org/officeDocument/2006/relationships" xmlns:p="http://schemas.openxmlformats.org/presentationml/2006/main">
   <p:cSld name="Slide 1">
     <p:spTree>
@@ -1048,48 +1212,9 @@
                 <a:ea typeface="Cambria" pitchFamily="34" charset="-122"/>
                 <a:cs typeface="Cambria" pitchFamily="34" charset="-120"/>
               </a:rPr>
-              <a:t>Issue 1 — 卡片標題字體大小不一致</a:t>
+              <a:t>卡片標題字體大小統一</a:t>
             </a:r>
             <a:endParaRPr lang="en-US" sz="2000" dirty="0"/>
-          </a:p>
-        </p:txBody>
-      </p:sp>
-      <p:sp>
-        <p:nvSpPr>
-          <p:cNvPr id="4" name="Text 2"/>
-          <p:cNvSpPr txBox="1"/>
-          <p:nvPr/>
-        </p:nvSpPr>
-        <p:spPr>
-          <a:xfrm>
-            <a:off x="365760" y="777240"/>
-            <a:ext cx="5486400" cy="274320"/>
-          </a:xfrm>
-          <a:prstGeom prst="rect">
-            <a:avLst/>
-          </a:prstGeom>
-          <a:noFill/>
-          <a:ln/>
-        </p:spPr>
-        <p:txBody>
-          <a:bodyPr wrap="square" rtlCol="0" anchor="ctr"/>
-          <a:lstStyle/>
-          <a:p>
-            <a:pPr marL="0" indent="0">
-              <a:buNone/>
-            </a:pPr>
-            <a:r>
-              <a:rPr lang="en-US" sz="1800" dirty="0">
-                <a:solidFill>
-                  <a:srgbClr val="5A6B78"/>
-                </a:solidFill>
-                <a:latin typeface="Calibri" pitchFamily="34" charset="0"/>
-                <a:ea typeface="Calibri" pitchFamily="34" charset="-122"/>
-                <a:cs typeface="Calibri" pitchFamily="34" charset="-120"/>
-              </a:rPr>
-              <a:t>研究方向</a:t>
-            </a:r>
-            <a:endParaRPr lang="en-US" sz="1200" dirty="0"/>
           </a:p>
         </p:txBody>
       </p:sp>
@@ -1686,8 +1811,9 @@
             <a:r>
               <a:rPr sz="1800">
                 <a:solidFill>
-                  <a:srgbClr val="1F1F1F"/>
-                </a:solidFill>
+                  <a:srgbClr val="5A6B78"/>
+                </a:solidFill>
+                <a:latin typeface="Calibri"/>
               </a:rPr>
               <a:t>2</a:t>
             </a:r>
@@ -1702,7 +1828,7 @@
 </p:sld>
 </file>
 
-<file path=ppt/slides/slide2.xml><?xml version="1.0" encoding="utf-8"?>
+<file path=ppt/slides/slide3.xml><?xml version="1.0" encoding="utf-8"?>
 <p:sld xmlns:a="http://schemas.openxmlformats.org/drawingml/2006/main" xmlns:r="http://schemas.openxmlformats.org/officeDocument/2006/relationships" xmlns:p="http://schemas.openxmlformats.org/presentationml/2006/main">
   <p:cSld name="Slide 2">
     <p:spTree>
@@ -1776,7 +1902,7 @@
                 <a:ea typeface="Cambria" pitchFamily="34" charset="-122"/>
                 <a:cs typeface="Cambria" pitchFamily="34" charset="-120"/>
               </a:rPr>
-              <a:t>Issue 2 — 文字框超出卡片寬度 ＆ 數字與標題間距過大</a:t>
+              <a:t>文字框限於卡片寬度、數字與標題間距一致</a:t>
             </a:r>
             <a:endParaRPr lang="en-US" sz="2000" dirty="0"/>
           </a:p>
@@ -1790,8 +1916,8 @@
         </p:nvSpPr>
         <p:spPr>
           <a:xfrm>
-            <a:off x="1371600" y="914400"/>
-            <a:ext cx="2514600" cy="4572000"/>
+            <a:off x="1371600" y="1371600"/>
+            <a:ext cx="2514600" cy="3931920"/>
           </a:xfrm>
           <a:prstGeom prst="roundRect">
             <a:avLst>
@@ -1821,7 +1947,7 @@
         </p:nvSpPr>
         <p:spPr>
           <a:xfrm>
-            <a:off x="1691640" y="1234440"/>
+            <a:off x="1691640" y="1691640"/>
             <a:ext cx="594360" cy="594360"/>
           </a:xfrm>
           <a:prstGeom prst="ellipse">
@@ -1845,7 +1971,7 @@
         </p:nvSpPr>
         <p:spPr>
           <a:xfrm>
-            <a:off x="1691640" y="1234440"/>
+            <a:off x="1691640" y="1691640"/>
             <a:ext cx="594360" cy="594360"/>
           </a:xfrm>
           <a:prstGeom prst="rect">
@@ -1884,7 +2010,7 @@
         </p:nvSpPr>
         <p:spPr>
           <a:xfrm>
-            <a:off x="1554480" y="1965960"/>
+            <a:off x="1554480" y="2514600"/>
             <a:ext cx="2148840" cy="731520"/>
           </a:xfrm>
           <a:prstGeom prst="rect">
@@ -1923,8 +2049,8 @@
         </p:nvSpPr>
         <p:spPr>
           <a:xfrm>
-            <a:off x="1554480" y="2834640"/>
-            <a:ext cx="2148840" cy="1371600"/>
+            <a:off x="1554480" y="3383280"/>
+            <a:ext cx="2148840" cy="1463040"/>
           </a:xfrm>
           <a:prstGeom prst="rect">
             <a:avLst/>
@@ -1963,8 +2089,8 @@
         </p:nvSpPr>
         <p:spPr>
           <a:xfrm>
-            <a:off x="6858000" y="914400"/>
-            <a:ext cx="2514600" cy="4572000"/>
+            <a:off x="6858000" y="1371600"/>
+            <a:ext cx="2514600" cy="3931920"/>
           </a:xfrm>
           <a:prstGeom prst="roundRect">
             <a:avLst>
@@ -1994,7 +2120,7 @@
         </p:nvSpPr>
         <p:spPr>
           <a:xfrm>
-            <a:off x="7178040" y="1234440"/>
+            <a:off x="7178040" y="1691640"/>
             <a:ext cx="594360" cy="594360"/>
           </a:xfrm>
           <a:prstGeom prst="ellipse">
@@ -2018,7 +2144,7 @@
         </p:nvSpPr>
         <p:spPr>
           <a:xfrm>
-            <a:off x="7178040" y="1234440"/>
+            <a:off x="7178040" y="1691640"/>
             <a:ext cx="594360" cy="594360"/>
           </a:xfrm>
           <a:prstGeom prst="rect">
@@ -2057,7 +2183,7 @@
         </p:nvSpPr>
         <p:spPr>
           <a:xfrm>
-            <a:off x="7040880" y="1965960"/>
+            <a:off x="7040880" y="2514600"/>
             <a:ext cx="2148840" cy="731520"/>
           </a:xfrm>
           <a:prstGeom prst="rect">
@@ -2096,8 +2222,8 @@
         </p:nvSpPr>
         <p:spPr>
           <a:xfrm>
-            <a:off x="7040880" y="2834640"/>
-            <a:ext cx="2148840" cy="1371600"/>
+            <a:off x="7040880" y="3383280"/>
+            <a:ext cx="2148840" cy="1463040"/>
           </a:xfrm>
           <a:prstGeom prst="rect">
             <a:avLst/>
@@ -2136,8 +2262,8 @@
         </p:nvSpPr>
         <p:spPr>
           <a:xfrm>
-            <a:off x="6858000" y="5577840"/>
-            <a:ext cx="2514600" cy="274320"/>
+            <a:off x="1371600" y="5486400"/>
+            <a:ext cx="8001000" cy="457200"/>
           </a:xfrm>
           <a:prstGeom prst="rect">
             <a:avLst/>
@@ -2161,7 +2287,7 @@
                 <a:ea typeface="Calibri" pitchFamily="34" charset="-122"/>
                 <a:cs typeface="Calibri" pitchFamily="34" charset="-120"/>
               </a:rPr>
-              <a:t>文字框邊界 = 卡片邊界  ✓</a:t>
+              <a:t>兩張卡片：文字框邊界 = 卡片邊界  ✓</a:t>
             </a:r>
             <a:endParaRPr lang="en-US" sz="900" dirty="0"/>
           </a:p>
@@ -2193,8 +2319,9 @@
             <a:r>
               <a:rPr sz="1800">
                 <a:solidFill>
-                  <a:srgbClr val="1F1F1F"/>
-                </a:solidFill>
+                  <a:srgbClr val="5A6B78"/>
+                </a:solidFill>
+                <a:latin typeface="Calibri"/>
               </a:rPr>
               <a:t>3</a:t>
             </a:r>
@@ -2209,7 +2336,7 @@
 </p:sld>
 </file>
 
-<file path=ppt/slides/slide3.xml><?xml version="1.0" encoding="utf-8"?>
+<file path=ppt/slides/slide4.xml><?xml version="1.0" encoding="utf-8"?>
 <p:sld xmlns:a="http://schemas.openxmlformats.org/drawingml/2006/main" xmlns:r="http://schemas.openxmlformats.org/officeDocument/2006/relationships" xmlns:p="http://schemas.openxmlformats.org/presentationml/2006/main">
   <p:cSld name="Slide 3">
     <p:spTree>
@@ -2283,7 +2410,7 @@
                 <a:ea typeface="Cambria" pitchFamily="34" charset="-122"/>
                 <a:cs typeface="Cambria" pitchFamily="34" charset="-120"/>
               </a:rPr>
-              <a:t>Issue 3 — 卡片數字圓圈垂直基線不一致</a:t>
+              <a:t>卡片數字圓圈垂直基線對齊</a:t>
             </a:r>
             <a:endParaRPr lang="en-US" sz="2000" dirty="0"/>
           </a:p>
@@ -2291,13 +2418,13 @@
       </p:sp>
       <p:sp>
         <p:nvSpPr>
-          <p:cNvPr id="6" name="Shape 4"/>
+          <p:cNvPr id="5" name="Shape 3"/>
           <p:cNvSpPr/>
           <p:nvPr/>
         </p:nvSpPr>
         <p:spPr>
           <a:xfrm>
-            <a:off x="457200" y="1645920"/>
+            <a:off x="457200" y="1371600"/>
             <a:ext cx="2514600" cy="3931920"/>
           </a:xfrm>
           <a:prstGeom prst="roundRect">
@@ -2322,13 +2449,13 @@
       </p:sp>
       <p:sp>
         <p:nvSpPr>
-          <p:cNvPr id="7" name="Shape 5"/>
+          <p:cNvPr id="6" name="Shape 4"/>
           <p:cNvSpPr/>
           <p:nvPr/>
         </p:nvSpPr>
         <p:spPr>
           <a:xfrm>
-            <a:off x="777240" y="1965960"/>
+            <a:off x="777240" y="1691640"/>
             <a:ext cx="594360" cy="594360"/>
           </a:xfrm>
           <a:prstGeom prst="ellipse">
@@ -2346,14 +2473,53 @@
       </p:sp>
       <p:sp>
         <p:nvSpPr>
+          <p:cNvPr id="7" name="Text 5"/>
+          <p:cNvSpPr txBox="1"/>
+          <p:nvPr/>
+        </p:nvSpPr>
+        <p:spPr>
+          <a:xfrm>
+            <a:off x="777240" y="1691640"/>
+            <a:ext cx="594360" cy="594360"/>
+          </a:xfrm>
+          <a:prstGeom prst="rect">
+            <a:avLst/>
+          </a:prstGeom>
+          <a:noFill/>
+          <a:ln/>
+        </p:spPr>
+        <p:txBody>
+          <a:bodyPr wrap="square" lIns="0" tIns="0" rIns="0" bIns="0" rtlCol="0" anchor="ctr"/>
+          <a:lstStyle/>
+          <a:p>
+            <a:pPr marL="0" indent="0" algn="ctr">
+              <a:buNone/>
+            </a:pPr>
+            <a:r>
+              <a:rPr lang="en-US" sz="1800" b="1" dirty="0">
+                <a:solidFill>
+                  <a:srgbClr val="FFFFFF"/>
+                </a:solidFill>
+                <a:latin typeface="Calibri" pitchFamily="34" charset="0"/>
+                <a:ea typeface="Calibri" pitchFamily="34" charset="-122"/>
+                <a:cs typeface="Calibri" pitchFamily="34" charset="-120"/>
+              </a:rPr>
+              <a:t>1</a:t>
+            </a:r>
+            <a:endParaRPr lang="en-US" sz="1800" dirty="0"/>
+          </a:p>
+        </p:txBody>
+      </p:sp>
+      <p:sp>
+        <p:nvSpPr>
           <p:cNvPr id="8" name="Text 6"/>
           <p:cNvSpPr txBox="1"/>
           <p:nvPr/>
         </p:nvSpPr>
         <p:spPr>
           <a:xfrm>
-            <a:off x="777240" y="1965960"/>
-            <a:ext cx="594360" cy="594360"/>
+            <a:off x="640080" y="2514600"/>
+            <a:ext cx="2148840" cy="731520"/>
           </a:xfrm>
           <a:prstGeom prst="rect">
             <a:avLst/>
@@ -2365,21 +2531,21 @@
           <a:bodyPr wrap="square" lIns="0" tIns="0" rIns="0" bIns="0" rtlCol="0" anchor="ctr"/>
           <a:lstStyle/>
           <a:p>
-            <a:pPr marL="0" indent="0" algn="ctr">
-              <a:buNone/>
-            </a:pPr>
-            <a:r>
-              <a:rPr lang="en-US" sz="1800" b="1" dirty="0">
-                <a:solidFill>
-                  <a:srgbClr val="FFFFFF"/>
-                </a:solidFill>
-                <a:latin typeface="Calibri" pitchFamily="34" charset="0"/>
-                <a:ea typeface="Calibri" pitchFamily="34" charset="-122"/>
-                <a:cs typeface="Calibri" pitchFamily="34" charset="-120"/>
-              </a:rPr>
-              <a:t>1</a:t>
-            </a:r>
-            <a:endParaRPr lang="en-US" sz="1800" dirty="0"/>
+            <a:pPr marL="0" indent="0">
+              <a:buNone/>
+            </a:pPr>
+            <a:r>
+              <a:rPr lang="en-US" sz="2000" b="1" dirty="0">
+                <a:solidFill>
+                  <a:srgbClr val="1B2430"/>
+                </a:solidFill>
+                <a:latin typeface="Calibri" pitchFamily="34" charset="0"/>
+                <a:ea typeface="Calibri" pitchFamily="34" charset="-122"/>
+                <a:cs typeface="Calibri" pitchFamily="34" charset="-120"/>
+              </a:rPr>
+              <a:t>探究式學習</a:t>
+            </a:r>
+            <a:endParaRPr lang="en-US" sz="1600" dirty="0"/>
           </a:p>
         </p:txBody>
       </p:sp>
@@ -2391,46 +2557,63 @@
         </p:nvSpPr>
         <p:spPr>
           <a:xfrm>
-            <a:off x="640080" y="2788920"/>
-            <a:ext cx="2148840" cy="731520"/>
-          </a:xfrm>
-          <a:prstGeom prst="rect">
-            <a:avLst/>
-          </a:prstGeom>
-          <a:noFill/>
-          <a:ln/>
-        </p:spPr>
-        <p:txBody>
-          <a:bodyPr wrap="square" lIns="0" tIns="0" rIns="0" bIns="0" rtlCol="0" anchor="ctr"/>
+            <a:off x="640080" y="3383280"/>
+            <a:ext cx="2148840" cy="1463040"/>
+          </a:xfrm>
+          <a:prstGeom prst="rect">
+            <a:avLst/>
+          </a:prstGeom>
+          <a:noFill/>
+          <a:ln/>
+        </p:spPr>
+        <p:txBody>
+          <a:bodyPr wrap="square" lIns="0" tIns="0" rIns="0" bIns="0" rtlCol="0" anchor="t"/>
           <a:lstStyle/>
           <a:p>
             <a:pPr marL="0" indent="0">
               <a:buNone/>
             </a:pPr>
             <a:r>
-              <a:rPr lang="en-US" sz="2000" b="1" dirty="0">
-                <a:solidFill>
-                  <a:srgbClr val="1B2430"/>
-                </a:solidFill>
-                <a:latin typeface="Calibri" pitchFamily="34" charset="0"/>
-                <a:ea typeface="Calibri" pitchFamily="34" charset="-122"/>
-                <a:cs typeface="Calibri" pitchFamily="34" charset="-120"/>
-              </a:rPr>
-              <a:t>探究式學習</a:t>
-            </a:r>
-            <a:endParaRPr lang="en-US" sz="1600" dirty="0"/>
-          </a:p>
-        </p:txBody>
-      </p:sp>
-      <p:sp>
-        <p:nvSpPr>
-          <p:cNvPr id="11" name="Shape 9"/>
+              <a:rPr lang="en-US" sz="1800" dirty="0">
+                <a:solidFill>
+                  <a:srgbClr val="5A6B78"/>
+                </a:solidFill>
+                <a:latin typeface="Calibri" pitchFamily="34" charset="0"/>
+                <a:ea typeface="Calibri" pitchFamily="34" charset="-122"/>
+                <a:cs typeface="Calibri" pitchFamily="34" charset="-120"/>
+              </a:rPr>
+              <a:t>Inquiry-Based Learning</a:t>
+            </a:r>
+            <a:endParaRPr lang="en-US" sz="1000" dirty="0"/>
+          </a:p>
+          <a:p>
+            <a:pPr marL="0" indent="0">
+              <a:buNone/>
+            </a:pPr>
+            <a:r>
+              <a:rPr lang="en-US" sz="1800" dirty="0">
+                <a:solidFill>
+                  <a:srgbClr val="5A6B78"/>
+                </a:solidFill>
+                <a:latin typeface="Calibri" pitchFamily="34" charset="0"/>
+                <a:ea typeface="Calibri" pitchFamily="34" charset="-122"/>
+                <a:cs typeface="Calibri" pitchFamily="34" charset="-120"/>
+              </a:rPr>
+              <a:t>探討學生科學探究歷程與學習成效</a:t>
+            </a:r>
+            <a:endParaRPr lang="en-US" sz="1000" dirty="0"/>
+          </a:p>
+        </p:txBody>
+      </p:sp>
+      <p:sp>
+        <p:nvSpPr>
+          <p:cNvPr id="10" name="Shape 8"/>
           <p:cNvSpPr/>
           <p:nvPr/>
         </p:nvSpPr>
         <p:spPr>
           <a:xfrm>
-            <a:off x="3383280" y="1645920"/>
+            <a:off x="3383280" y="1371600"/>
             <a:ext cx="2514600" cy="3931920"/>
           </a:xfrm>
           <a:prstGeom prst="roundRect">
@@ -2455,13 +2638,13 @@
       </p:sp>
       <p:sp>
         <p:nvSpPr>
-          <p:cNvPr id="12" name="Shape 10"/>
+          <p:cNvPr id="11" name="Shape 9"/>
           <p:cNvSpPr/>
           <p:nvPr/>
         </p:nvSpPr>
         <p:spPr>
           <a:xfrm>
-            <a:off x="3703320" y="1965960"/>
+            <a:off x="3703320" y="1691640"/>
             <a:ext cx="594360" cy="594360"/>
           </a:xfrm>
           <a:prstGeom prst="ellipse">
@@ -2479,14 +2662,53 @@
       </p:sp>
       <p:sp>
         <p:nvSpPr>
+          <p:cNvPr id="12" name="Text 10"/>
+          <p:cNvSpPr txBox="1"/>
+          <p:nvPr/>
+        </p:nvSpPr>
+        <p:spPr>
+          <a:xfrm>
+            <a:off x="3703320" y="1691640"/>
+            <a:ext cx="594360" cy="594360"/>
+          </a:xfrm>
+          <a:prstGeom prst="rect">
+            <a:avLst/>
+          </a:prstGeom>
+          <a:noFill/>
+          <a:ln/>
+        </p:spPr>
+        <p:txBody>
+          <a:bodyPr wrap="square" lIns="0" tIns="0" rIns="0" bIns="0" rtlCol="0" anchor="ctr"/>
+          <a:lstStyle/>
+          <a:p>
+            <a:pPr marL="0" indent="0" algn="ctr">
+              <a:buNone/>
+            </a:pPr>
+            <a:r>
+              <a:rPr lang="en-US" sz="1800" b="1" dirty="0">
+                <a:solidFill>
+                  <a:srgbClr val="FFFFFF"/>
+                </a:solidFill>
+                <a:latin typeface="Calibri" pitchFamily="34" charset="0"/>
+                <a:ea typeface="Calibri" pitchFamily="34" charset="-122"/>
+                <a:cs typeface="Calibri" pitchFamily="34" charset="-120"/>
+              </a:rPr>
+              <a:t>2</a:t>
+            </a:r>
+            <a:endParaRPr lang="en-US" sz="1800" dirty="0"/>
+          </a:p>
+        </p:txBody>
+      </p:sp>
+      <p:sp>
+        <p:nvSpPr>
           <p:cNvPr id="13" name="Text 11"/>
           <p:cNvSpPr txBox="1"/>
           <p:nvPr/>
         </p:nvSpPr>
         <p:spPr>
           <a:xfrm>
-            <a:off x="3703320" y="1965960"/>
-            <a:ext cx="594360" cy="594360"/>
+            <a:off x="3566160" y="2514600"/>
+            <a:ext cx="2148840" cy="731520"/>
           </a:xfrm>
           <a:prstGeom prst="rect">
             <a:avLst/>
@@ -2498,21 +2720,21 @@
           <a:bodyPr wrap="square" lIns="0" tIns="0" rIns="0" bIns="0" rtlCol="0" anchor="ctr"/>
           <a:lstStyle/>
           <a:p>
-            <a:pPr marL="0" indent="0" algn="ctr">
-              <a:buNone/>
-            </a:pPr>
-            <a:r>
-              <a:rPr lang="en-US" sz="1800" b="1" dirty="0">
-                <a:solidFill>
-                  <a:srgbClr val="FFFFFF"/>
-                </a:solidFill>
-                <a:latin typeface="Calibri" pitchFamily="34" charset="0"/>
-                <a:ea typeface="Calibri" pitchFamily="34" charset="-122"/>
-                <a:cs typeface="Calibri" pitchFamily="34" charset="-120"/>
-              </a:rPr>
-              <a:t>2</a:t>
-            </a:r>
-            <a:endParaRPr lang="en-US" sz="1800" dirty="0"/>
+            <a:pPr marL="0" indent="0">
+              <a:buNone/>
+            </a:pPr>
+            <a:r>
+              <a:rPr lang="en-US" sz="2000" b="1" dirty="0">
+                <a:solidFill>
+                  <a:srgbClr val="1B2430"/>
+                </a:solidFill>
+                <a:latin typeface="Calibri" pitchFamily="34" charset="0"/>
+                <a:ea typeface="Calibri" pitchFamily="34" charset="-122"/>
+                <a:cs typeface="Calibri" pitchFamily="34" charset="-120"/>
+              </a:rPr>
+              <a:t>AI輔助適性學習系統</a:t>
+            </a:r>
+            <a:endParaRPr lang="en-US" sz="3600" dirty="0"/>
           </a:p>
         </p:txBody>
       </p:sp>
@@ -2524,46 +2746,63 @@
         </p:nvSpPr>
         <p:spPr>
           <a:xfrm>
-            <a:off x="3566160" y="2788920"/>
-            <a:ext cx="2148840" cy="731520"/>
-          </a:xfrm>
-          <a:prstGeom prst="rect">
-            <a:avLst/>
-          </a:prstGeom>
-          <a:noFill/>
-          <a:ln/>
-        </p:spPr>
-        <p:txBody>
-          <a:bodyPr wrap="square" lIns="0" tIns="0" rIns="0" bIns="0" rtlCol="0" anchor="ctr"/>
+            <a:off x="3566160" y="3383280"/>
+            <a:ext cx="2148840" cy="1463040"/>
+          </a:xfrm>
+          <a:prstGeom prst="rect">
+            <a:avLst/>
+          </a:prstGeom>
+          <a:noFill/>
+          <a:ln/>
+        </p:spPr>
+        <p:txBody>
+          <a:bodyPr wrap="square" lIns="0" tIns="0" rIns="0" bIns="0" rtlCol="0" anchor="t"/>
           <a:lstStyle/>
           <a:p>
             <a:pPr marL="0" indent="0">
               <a:buNone/>
             </a:pPr>
             <a:r>
-              <a:rPr lang="en-US" sz="2000" b="1" dirty="0">
-                <a:solidFill>
-                  <a:srgbClr val="1B2430"/>
-                </a:solidFill>
-                <a:latin typeface="Calibri" pitchFamily="34" charset="0"/>
-                <a:ea typeface="Calibri" pitchFamily="34" charset="-122"/>
-                <a:cs typeface="Calibri" pitchFamily="34" charset="-120"/>
-              </a:rPr>
-              <a:t>AI輔助適性學習系統</a:t>
-            </a:r>
-            <a:endParaRPr lang="en-US" sz="1600" dirty="0"/>
-          </a:p>
-        </p:txBody>
-      </p:sp>
-      <p:sp>
-        <p:nvSpPr>
-          <p:cNvPr id="16" name="Shape 14"/>
+              <a:rPr lang="en-US" sz="1800" dirty="0">
+                <a:solidFill>
+                  <a:srgbClr val="5A6B78"/>
+                </a:solidFill>
+                <a:latin typeface="Calibri" pitchFamily="34" charset="0"/>
+                <a:ea typeface="Calibri" pitchFamily="34" charset="-122"/>
+                <a:cs typeface="Calibri" pitchFamily="34" charset="-120"/>
+              </a:rPr>
+              <a:t>Adaptive Learning System</a:t>
+            </a:r>
+            <a:endParaRPr lang="en-US" sz="1000" dirty="0"/>
+          </a:p>
+          <a:p>
+            <a:pPr marL="0" indent="0">
+              <a:buNone/>
+            </a:pPr>
+            <a:r>
+              <a:rPr lang="en-US" sz="1800" dirty="0">
+                <a:solidFill>
+                  <a:srgbClr val="5A6B78"/>
+                </a:solidFill>
+                <a:latin typeface="Calibri" pitchFamily="34" charset="0"/>
+                <a:ea typeface="Calibri" pitchFamily="34" charset="-122"/>
+                <a:cs typeface="Calibri" pitchFamily="34" charset="-120"/>
+              </a:rPr>
+              <a:t>發展個人化、適性化的智慧學習環境</a:t>
+            </a:r>
+            <a:endParaRPr lang="en-US" sz="1000" dirty="0"/>
+          </a:p>
+        </p:txBody>
+      </p:sp>
+      <p:sp>
+        <p:nvSpPr>
+          <p:cNvPr id="15" name="Shape 13"/>
           <p:cNvSpPr/>
           <p:nvPr/>
         </p:nvSpPr>
         <p:spPr>
           <a:xfrm>
-            <a:off x="6309360" y="1645920"/>
+            <a:off x="6309360" y="1371600"/>
             <a:ext cx="2514600" cy="3931920"/>
           </a:xfrm>
           <a:prstGeom prst="roundRect">
@@ -2588,13 +2827,13 @@
       </p:sp>
       <p:sp>
         <p:nvSpPr>
-          <p:cNvPr id="17" name="Shape 15"/>
+          <p:cNvPr id="16" name="Shape 14"/>
           <p:cNvSpPr/>
           <p:nvPr/>
         </p:nvSpPr>
         <p:spPr>
           <a:xfrm>
-            <a:off x="6629400" y="1965960"/>
+            <a:off x="6629400" y="1691640"/>
             <a:ext cx="594360" cy="594360"/>
           </a:xfrm>
           <a:prstGeom prst="ellipse">
@@ -2612,14 +2851,53 @@
       </p:sp>
       <p:sp>
         <p:nvSpPr>
+          <p:cNvPr id="17" name="Text 15"/>
+          <p:cNvSpPr txBox="1"/>
+          <p:nvPr/>
+        </p:nvSpPr>
+        <p:spPr>
+          <a:xfrm>
+            <a:off x="6629400" y="1691640"/>
+            <a:ext cx="594360" cy="594360"/>
+          </a:xfrm>
+          <a:prstGeom prst="rect">
+            <a:avLst/>
+          </a:prstGeom>
+          <a:noFill/>
+          <a:ln/>
+        </p:spPr>
+        <p:txBody>
+          <a:bodyPr wrap="square" lIns="0" tIns="0" rIns="0" bIns="0" rtlCol="0" anchor="ctr"/>
+          <a:lstStyle/>
+          <a:p>
+            <a:pPr marL="0" indent="0" algn="ctr">
+              <a:buNone/>
+            </a:pPr>
+            <a:r>
+              <a:rPr lang="en-US" sz="1800" b="1" dirty="0">
+                <a:solidFill>
+                  <a:srgbClr val="FFFFFF"/>
+                </a:solidFill>
+                <a:latin typeface="Calibri" pitchFamily="34" charset="0"/>
+                <a:ea typeface="Calibri" pitchFamily="34" charset="-122"/>
+                <a:cs typeface="Calibri" pitchFamily="34" charset="-120"/>
+              </a:rPr>
+              <a:t>3</a:t>
+            </a:r>
+            <a:endParaRPr lang="en-US" sz="1800" dirty="0"/>
+          </a:p>
+        </p:txBody>
+      </p:sp>
+      <p:sp>
+        <p:nvSpPr>
           <p:cNvPr id="18" name="Text 16"/>
           <p:cNvSpPr txBox="1"/>
           <p:nvPr/>
         </p:nvSpPr>
         <p:spPr>
           <a:xfrm>
-            <a:off x="6629400" y="1965960"/>
-            <a:ext cx="594360" cy="594360"/>
+            <a:off x="6492240" y="2514600"/>
+            <a:ext cx="2148840" cy="731520"/>
           </a:xfrm>
           <a:prstGeom prst="rect">
             <a:avLst/>
@@ -2631,21 +2909,21 @@
           <a:bodyPr wrap="square" lIns="0" tIns="0" rIns="0" bIns="0" rtlCol="0" anchor="ctr"/>
           <a:lstStyle/>
           <a:p>
-            <a:pPr marL="0" indent="0" algn="ctr">
-              <a:buNone/>
-            </a:pPr>
-            <a:r>
-              <a:rPr lang="en-US" sz="1800" b="1" dirty="0">
-                <a:solidFill>
-                  <a:srgbClr val="FFFFFF"/>
-                </a:solidFill>
-                <a:latin typeface="Calibri" pitchFamily="34" charset="0"/>
-                <a:ea typeface="Calibri" pitchFamily="34" charset="-122"/>
-                <a:cs typeface="Calibri" pitchFamily="34" charset="-120"/>
-              </a:rPr>
-              <a:t>3</a:t>
-            </a:r>
-            <a:endParaRPr lang="en-US" sz="1800" dirty="0"/>
+            <a:pPr marL="0" indent="0">
+              <a:buNone/>
+            </a:pPr>
+            <a:r>
+              <a:rPr lang="en-US" sz="2000" b="1" dirty="0">
+                <a:solidFill>
+                  <a:srgbClr val="1B2430"/>
+                </a:solidFill>
+                <a:latin typeface="Calibri" pitchFamily="34" charset="0"/>
+                <a:ea typeface="Calibri" pitchFamily="34" charset="-122"/>
+                <a:cs typeface="Calibri" pitchFamily="34" charset="-120"/>
+              </a:rPr>
+              <a:t>氣候變遷教育</a:t>
+            </a:r>
+            <a:endParaRPr lang="en-US" sz="1600" dirty="0"/>
           </a:p>
         </p:txBody>
       </p:sp>
@@ -2657,34 +2935,51 @@
         </p:nvSpPr>
         <p:spPr>
           <a:xfrm>
-            <a:off x="6492240" y="2788920"/>
-            <a:ext cx="2148840" cy="731520"/>
-          </a:xfrm>
-          <a:prstGeom prst="rect">
-            <a:avLst/>
-          </a:prstGeom>
-          <a:noFill/>
-          <a:ln/>
-        </p:spPr>
-        <p:txBody>
-          <a:bodyPr wrap="square" lIns="0" tIns="0" rIns="0" bIns="0" rtlCol="0" anchor="ctr"/>
+            <a:off x="6492240" y="3383280"/>
+            <a:ext cx="2148840" cy="1463040"/>
+          </a:xfrm>
+          <a:prstGeom prst="rect">
+            <a:avLst/>
+          </a:prstGeom>
+          <a:noFill/>
+          <a:ln/>
+        </p:spPr>
+        <p:txBody>
+          <a:bodyPr wrap="square" lIns="0" tIns="0" rIns="0" bIns="0" rtlCol="0" anchor="t"/>
           <a:lstStyle/>
           <a:p>
             <a:pPr marL="0" indent="0">
               <a:buNone/>
             </a:pPr>
             <a:r>
-              <a:rPr lang="en-US" sz="2000" b="1" dirty="0">
-                <a:solidFill>
-                  <a:srgbClr val="1B2430"/>
-                </a:solidFill>
-                <a:latin typeface="Calibri" pitchFamily="34" charset="0"/>
-                <a:ea typeface="Calibri" pitchFamily="34" charset="-122"/>
-                <a:cs typeface="Calibri" pitchFamily="34" charset="-120"/>
-              </a:rPr>
-              <a:t>氣候變遷教育</a:t>
-            </a:r>
-            <a:endParaRPr lang="en-US" sz="1600" dirty="0"/>
+              <a:rPr lang="en-US" sz="1800" dirty="0">
+                <a:solidFill>
+                  <a:srgbClr val="5A6B78"/>
+                </a:solidFill>
+                <a:latin typeface="Calibri" pitchFamily="34" charset="0"/>
+                <a:ea typeface="Calibri" pitchFamily="34" charset="-122"/>
+                <a:cs typeface="Calibri" pitchFamily="34" charset="-120"/>
+              </a:rPr>
+              <a:t>Climate Change Education</a:t>
+            </a:r>
+            <a:endParaRPr lang="en-US" sz="1000" dirty="0"/>
+          </a:p>
+          <a:p>
+            <a:pPr marL="0" indent="0">
+              <a:buNone/>
+            </a:pPr>
+            <a:r>
+              <a:rPr lang="en-US" sz="1800" dirty="0">
+                <a:solidFill>
+                  <a:srgbClr val="5A6B78"/>
+                </a:solidFill>
+                <a:latin typeface="Calibri" pitchFamily="34" charset="0"/>
+                <a:ea typeface="Calibri" pitchFamily="34" charset="-122"/>
+                <a:cs typeface="Calibri" pitchFamily="34" charset="-120"/>
+              </a:rPr>
+              <a:t>關注氣候素養與永續行動的教育設計</a:t>
+            </a:r>
+            <a:endParaRPr lang="en-US" sz="1000" dirty="0"/>
           </a:p>
         </p:txBody>
       </p:sp>
@@ -2714,8 +3009,9 @@
             <a:r>
               <a:rPr sz="1800">
                 <a:solidFill>
-                  <a:srgbClr val="1F1F1F"/>
-                </a:solidFill>
+                  <a:srgbClr val="5A6B78"/>
+                </a:solidFill>
+                <a:latin typeface="Calibri"/>
               </a:rPr>
               <a:t>4</a:t>
             </a:r>
@@ -2730,7 +3026,7 @@
 </p:sld>
 </file>
 
-<file path=ppt/slides/slide4.xml><?xml version="1.0" encoding="utf-8"?>
+<file path=ppt/slides/slide5.xml><?xml version="1.0" encoding="utf-8"?>
 <p:sld xmlns:a="http://schemas.openxmlformats.org/drawingml/2006/main" xmlns:r="http://schemas.openxmlformats.org/officeDocument/2006/relationships" xmlns:p="http://schemas.openxmlformats.org/presentationml/2006/main">
   <p:cSld name="Slide 4">
     <p:spTree>
@@ -2804,7 +3100,7 @@
                 <a:ea typeface="Cambria" pitchFamily="34" charset="-122"/>
                 <a:cs typeface="Cambria" pitchFamily="34" charset="-120"/>
               </a:rPr>
-              <a:t>Issue 4 — 標題與描述文字之間空白過大</a:t>
+              <a:t>標題與描述文字間距適中</a:t>
             </a:r>
             <a:endParaRPr lang="en-US" sz="2000" dirty="0"/>
           </a:p>
@@ -2818,8 +3114,8 @@
         </p:nvSpPr>
         <p:spPr>
           <a:xfrm>
-            <a:off x="457200" y="1097280"/>
-            <a:ext cx="2514600" cy="4389120"/>
+            <a:off x="457200" y="1371600"/>
+            <a:ext cx="2514600" cy="3931920"/>
           </a:xfrm>
           <a:prstGeom prst="roundRect">
             <a:avLst>
@@ -2849,7 +3145,7 @@
         </p:nvSpPr>
         <p:spPr>
           <a:xfrm>
-            <a:off x="777240" y="1417320"/>
+            <a:off x="777240" y="1691640"/>
             <a:ext cx="594360" cy="594360"/>
           </a:xfrm>
           <a:prstGeom prst="ellipse">
@@ -2873,7 +3169,7 @@
         </p:nvSpPr>
         <p:spPr>
           <a:xfrm>
-            <a:off x="777240" y="1417320"/>
+            <a:off x="777240" y="1691640"/>
             <a:ext cx="594360" cy="594360"/>
           </a:xfrm>
           <a:prstGeom prst="rect">
@@ -2912,8 +3208,8 @@
         </p:nvSpPr>
         <p:spPr>
           <a:xfrm>
-            <a:off x="640080" y="2240280"/>
-            <a:ext cx="2148840" cy="548640"/>
+            <a:off x="640080" y="2514600"/>
+            <a:ext cx="2148840" cy="731520"/>
           </a:xfrm>
           <a:prstGeom prst="rect">
             <a:avLst/>
@@ -2951,17 +3247,17 @@
         </p:nvSpPr>
         <p:spPr>
           <a:xfrm>
-            <a:off x="640080" y="2926080"/>
-            <a:ext cx="2148840" cy="1371600"/>
-          </a:xfrm>
-          <a:prstGeom prst="rect">
-            <a:avLst/>
-          </a:prstGeom>
-          <a:noFill/>
-          <a:ln/>
-        </p:spPr>
-        <p:txBody>
-          <a:bodyPr wrap="square" lIns="0" tIns="0" rIns="0" bIns="0" rtlCol="0" anchor="ctr"/>
+            <a:off x="640080" y="3383280"/>
+            <a:ext cx="2148840" cy="1463040"/>
+          </a:xfrm>
+          <a:prstGeom prst="rect">
+            <a:avLst/>
+          </a:prstGeom>
+          <a:noFill/>
+          <a:ln/>
+        </p:spPr>
+        <p:txBody>
+          <a:bodyPr wrap="square" lIns="0" tIns="0" rIns="0" bIns="0" rtlCol="0" anchor="t"/>
           <a:lstStyle/>
           <a:p>
             <a:pPr marL="0" indent="0">
@@ -3001,14 +3297,14 @@
       </p:sp>
       <p:sp>
         <p:nvSpPr>
-          <p:cNvPr id="13" name="Shape 11"/>
+          <p:cNvPr id="10" name="Shape 8"/>
           <p:cNvSpPr/>
           <p:nvPr/>
         </p:nvSpPr>
         <p:spPr>
           <a:xfrm>
-            <a:off x="3474720" y="1097280"/>
-            <a:ext cx="2514600" cy="4389120"/>
+            <a:off x="3383280" y="1371600"/>
+            <a:ext cx="2514600" cy="3931920"/>
           </a:xfrm>
           <a:prstGeom prst="roundRect">
             <a:avLst>
@@ -3032,20 +3328,20 @@
       </p:sp>
       <p:sp>
         <p:nvSpPr>
-          <p:cNvPr id="14" name="Shape 12"/>
+          <p:cNvPr id="11" name="Shape 9"/>
           <p:cNvSpPr/>
           <p:nvPr/>
         </p:nvSpPr>
         <p:spPr>
           <a:xfrm>
-            <a:off x="3794760" y="1417320"/>
+            <a:off x="3703320" y="1691640"/>
             <a:ext cx="594360" cy="594360"/>
           </a:xfrm>
           <a:prstGeom prst="ellipse">
             <a:avLst/>
           </a:prstGeom>
           <a:solidFill>
-            <a:srgbClr val="21295C"/>
+            <a:srgbClr val="1C7293"/>
           </a:solidFill>
           <a:ln/>
         </p:spPr>
@@ -3056,13 +3352,13 @@
       </p:sp>
       <p:sp>
         <p:nvSpPr>
-          <p:cNvPr id="15" name="Text 13"/>
-          <p:cNvSpPr txBox="1"/>
-          <p:nvPr/>
-        </p:nvSpPr>
-        <p:spPr>
-          <a:xfrm>
-            <a:off x="3794760" y="1417320"/>
+          <p:cNvPr id="12" name="Text 10"/>
+          <p:cNvSpPr txBox="1"/>
+          <p:nvPr/>
+        </p:nvSpPr>
+        <p:spPr>
+          <a:xfrm>
+            <a:off x="3703320" y="1691640"/>
             <a:ext cx="594360" cy="594360"/>
           </a:xfrm>
           <a:prstGeom prst="rect">
@@ -3087,6 +3383,195 @@
                 <a:ea typeface="Calibri" pitchFamily="34" charset="-122"/>
                 <a:cs typeface="Calibri" pitchFamily="34" charset="-120"/>
               </a:rPr>
+              <a:t>2</a:t>
+            </a:r>
+            <a:endParaRPr lang="en-US" sz="1800" dirty="0"/>
+          </a:p>
+        </p:txBody>
+      </p:sp>
+      <p:sp>
+        <p:nvSpPr>
+          <p:cNvPr id="13" name="Text 11"/>
+          <p:cNvSpPr txBox="1"/>
+          <p:nvPr/>
+        </p:nvSpPr>
+        <p:spPr>
+          <a:xfrm>
+            <a:off x="3566160" y="2514600"/>
+            <a:ext cx="2148840" cy="731520"/>
+          </a:xfrm>
+          <a:prstGeom prst="rect">
+            <a:avLst/>
+          </a:prstGeom>
+          <a:noFill/>
+          <a:ln/>
+        </p:spPr>
+        <p:txBody>
+          <a:bodyPr wrap="square" lIns="0" tIns="0" rIns="0" bIns="0" rtlCol="0" anchor="ctr"/>
+          <a:lstStyle/>
+          <a:p>
+            <a:pPr marL="0" indent="0">
+              <a:buNone/>
+            </a:pPr>
+            <a:r>
+              <a:rPr lang="en-US" sz="2000" b="1" dirty="0">
+                <a:solidFill>
+                  <a:srgbClr val="1B2430"/>
+                </a:solidFill>
+                <a:latin typeface="Calibri" pitchFamily="34" charset="0"/>
+                <a:ea typeface="Calibri" pitchFamily="34" charset="-122"/>
+                <a:cs typeface="Calibri" pitchFamily="34" charset="-120"/>
+              </a:rPr>
+              <a:t>AI輔助適性學習系統</a:t>
+            </a:r>
+            <a:endParaRPr lang="en-US" sz="3600" dirty="0"/>
+          </a:p>
+        </p:txBody>
+      </p:sp>
+      <p:sp>
+        <p:nvSpPr>
+          <p:cNvPr id="14" name="Text 12"/>
+          <p:cNvSpPr txBox="1"/>
+          <p:nvPr/>
+        </p:nvSpPr>
+        <p:spPr>
+          <a:xfrm>
+            <a:off x="3566160" y="3383280"/>
+            <a:ext cx="2148840" cy="1463040"/>
+          </a:xfrm>
+          <a:prstGeom prst="rect">
+            <a:avLst/>
+          </a:prstGeom>
+          <a:noFill/>
+          <a:ln/>
+        </p:spPr>
+        <p:txBody>
+          <a:bodyPr wrap="square" lIns="0" tIns="0" rIns="0" bIns="0" rtlCol="0" anchor="t"/>
+          <a:lstStyle/>
+          <a:p>
+            <a:pPr marL="0" indent="0">
+              <a:buNone/>
+            </a:pPr>
+            <a:r>
+              <a:rPr lang="en-US" sz="1800" dirty="0">
+                <a:solidFill>
+                  <a:srgbClr val="5A6B78"/>
+                </a:solidFill>
+                <a:latin typeface="Calibri" pitchFamily="34" charset="0"/>
+                <a:ea typeface="Calibri" pitchFamily="34" charset="-122"/>
+                <a:cs typeface="Calibri" pitchFamily="34" charset="-120"/>
+              </a:rPr>
+              <a:t>Adaptive Learning System</a:t>
+            </a:r>
+            <a:endParaRPr lang="en-US" sz="1000" dirty="0"/>
+          </a:p>
+          <a:p>
+            <a:pPr marL="0" indent="0">
+              <a:buNone/>
+            </a:pPr>
+            <a:r>
+              <a:rPr lang="en-US" sz="1800" dirty="0">
+                <a:solidFill>
+                  <a:srgbClr val="5A6B78"/>
+                </a:solidFill>
+                <a:latin typeface="Calibri" pitchFamily="34" charset="0"/>
+                <a:ea typeface="Calibri" pitchFamily="34" charset="-122"/>
+                <a:cs typeface="Calibri" pitchFamily="34" charset="-120"/>
+              </a:rPr>
+              <a:t>發展個人化、適性化的智慧學習環境</a:t>
+            </a:r>
+            <a:endParaRPr lang="en-US" sz="1000" dirty="0"/>
+          </a:p>
+        </p:txBody>
+      </p:sp>
+      <p:sp>
+        <p:nvSpPr>
+          <p:cNvPr id="15" name="Shape 13"/>
+          <p:cNvSpPr/>
+          <p:nvPr/>
+        </p:nvSpPr>
+        <p:spPr>
+          <a:xfrm>
+            <a:off x="6309360" y="1371600"/>
+            <a:ext cx="2514600" cy="3931920"/>
+          </a:xfrm>
+          <a:prstGeom prst="roundRect">
+            <a:avLst>
+              <a:gd name="adj" fmla="val 2909"/>
+            </a:avLst>
+          </a:prstGeom>
+          <a:solidFill>
+            <a:srgbClr val="F4F8FA"/>
+          </a:solidFill>
+          <a:ln w="6350">
+            <a:solidFill>
+              <a:srgbClr val="D0DDE5"/>
+            </a:solidFill>
+            <a:prstDash val="solid"/>
+          </a:ln>
+        </p:spPr>
+        <p:txBody>
+          <a:bodyPr/>
+          <a:p/>
+        </p:txBody>
+      </p:sp>
+      <p:sp>
+        <p:nvSpPr>
+          <p:cNvPr id="16" name="Shape 14"/>
+          <p:cNvSpPr/>
+          <p:nvPr/>
+        </p:nvSpPr>
+        <p:spPr>
+          <a:xfrm>
+            <a:off x="6629400" y="1691640"/>
+            <a:ext cx="594360" cy="594360"/>
+          </a:xfrm>
+          <a:prstGeom prst="ellipse">
+            <a:avLst/>
+          </a:prstGeom>
+          <a:solidFill>
+            <a:srgbClr val="21295C"/>
+          </a:solidFill>
+          <a:ln/>
+        </p:spPr>
+        <p:txBody>
+          <a:bodyPr/>
+          <a:p/>
+        </p:txBody>
+      </p:sp>
+      <p:sp>
+        <p:nvSpPr>
+          <p:cNvPr id="17" name="Text 15"/>
+          <p:cNvSpPr txBox="1"/>
+          <p:nvPr/>
+        </p:nvSpPr>
+        <p:spPr>
+          <a:xfrm>
+            <a:off x="6629400" y="1691640"/>
+            <a:ext cx="594360" cy="594360"/>
+          </a:xfrm>
+          <a:prstGeom prst="rect">
+            <a:avLst/>
+          </a:prstGeom>
+          <a:noFill/>
+          <a:ln/>
+        </p:spPr>
+        <p:txBody>
+          <a:bodyPr wrap="square" lIns="0" tIns="0" rIns="0" bIns="0" rtlCol="0" anchor="ctr"/>
+          <a:lstStyle/>
+          <a:p>
+            <a:pPr marL="0" indent="0" algn="ctr">
+              <a:buNone/>
+            </a:pPr>
+            <a:r>
+              <a:rPr lang="en-US" sz="1800" b="1" dirty="0">
+                <a:solidFill>
+                  <a:srgbClr val="FFFFFF"/>
+                </a:solidFill>
+                <a:latin typeface="Calibri" pitchFamily="34" charset="0"/>
+                <a:ea typeface="Calibri" pitchFamily="34" charset="-122"/>
+                <a:cs typeface="Calibri" pitchFamily="34" charset="-120"/>
+              </a:rPr>
               <a:t>3</a:t>
             </a:r>
             <a:endParaRPr lang="en-US" sz="1800" dirty="0"/>
@@ -3095,14 +3580,14 @@
       </p:sp>
       <p:sp>
         <p:nvSpPr>
-          <p:cNvPr id="16" name="Text 14"/>
-          <p:cNvSpPr txBox="1"/>
-          <p:nvPr/>
-        </p:nvSpPr>
-        <p:spPr>
-          <a:xfrm>
-            <a:off x="3657600" y="2240280"/>
-            <a:ext cx="2148840" cy="548640"/>
+          <p:cNvPr id="18" name="Text 16"/>
+          <p:cNvSpPr txBox="1"/>
+          <p:nvPr/>
+        </p:nvSpPr>
+        <p:spPr>
+          <a:xfrm>
+            <a:off x="6492240" y="2514600"/>
+            <a:ext cx="2148840" cy="731520"/>
           </a:xfrm>
           <a:prstGeom prst="rect">
             <a:avLst/>
@@ -3134,23 +3619,23 @@
       </p:sp>
       <p:sp>
         <p:nvSpPr>
-          <p:cNvPr id="17" name="Text 15"/>
-          <p:cNvSpPr txBox="1"/>
-          <p:nvPr/>
-        </p:nvSpPr>
-        <p:spPr>
-          <a:xfrm>
-            <a:off x="3657600" y="2926080"/>
-            <a:ext cx="2148840" cy="1371600"/>
-          </a:xfrm>
-          <a:prstGeom prst="rect">
-            <a:avLst/>
-          </a:prstGeom>
-          <a:noFill/>
-          <a:ln/>
-        </p:spPr>
-        <p:txBody>
-          <a:bodyPr wrap="square" lIns="0" tIns="0" rIns="0" bIns="0" rtlCol="0" anchor="ctr"/>
+          <p:cNvPr id="19" name="Text 17"/>
+          <p:cNvSpPr txBox="1"/>
+          <p:nvPr/>
+        </p:nvSpPr>
+        <p:spPr>
+          <a:xfrm>
+            <a:off x="6492240" y="3383280"/>
+            <a:ext cx="2148840" cy="1463040"/>
+          </a:xfrm>
+          <a:prstGeom prst="rect">
+            <a:avLst/>
+          </a:prstGeom>
+          <a:noFill/>
+          <a:ln/>
+        </p:spPr>
+        <p:txBody>
+          <a:bodyPr wrap="square" lIns="0" tIns="0" rIns="0" bIns="0" rtlCol="0" anchor="t"/>
           <a:lstStyle/>
           <a:p>
             <a:pPr marL="0" indent="0">
@@ -3214,8 +3699,9 @@
             <a:r>
               <a:rPr sz="1800">
                 <a:solidFill>
-                  <a:srgbClr val="1F1F1F"/>
-                </a:solidFill>
+                  <a:srgbClr val="5A6B78"/>
+                </a:solidFill>
+                <a:latin typeface="Calibri"/>
               </a:rPr>
               <a:t>5</a:t>
             </a:r>
@@ -3230,7 +3716,7 @@
 </p:sld>
 </file>
 
-<file path=ppt/slides/slide5.xml><?xml version="1.0" encoding="utf-8"?>
+<file path=ppt/slides/slide6.xml><?xml version="1.0" encoding="utf-8"?>
 <p:sld xmlns:a="http://schemas.openxmlformats.org/drawingml/2006/main" xmlns:r="http://schemas.openxmlformats.org/officeDocument/2006/relationships" xmlns:p="http://schemas.openxmlformats.org/presentationml/2006/main">
   <p:cSld name="Slide 5">
     <p:spTree>
@@ -3304,7 +3790,7 @@
                 <a:ea typeface="Cambria" pitchFamily="34" charset="-122"/>
                 <a:cs typeface="Cambria" pitchFamily="34" charset="-120"/>
               </a:rPr>
-              <a:t>Issue 5 — 前景色與背景色過於接近（低對比）</a:t>
+              <a:t>前景色與背景色高對比</a:t>
             </a:r>
             <a:endParaRPr lang="en-US" sz="2000" dirty="0"/>
           </a:p>
@@ -3326,346 +3812,6 @@
           </a:prstGeom>
           <a:solidFill>
             <a:srgbClr val="FFFFFF"/>
-          </a:solidFill>
-          <a:ln w="25400">
-            <a:solidFill>
-              <a:srgbClr val="E53935"/>
-            </a:solidFill>
-            <a:prstDash val="dash"/>
-          </a:ln>
-        </p:spPr>
-        <p:txBody>
-          <a:bodyPr/>
-          <a:p/>
-        </p:txBody>
-      </p:sp>
-      <p:sp>
-        <p:nvSpPr>
-          <p:cNvPr id="6" name="Text 4"/>
-          <p:cNvSpPr txBox="1"/>
-          <p:nvPr/>
-        </p:nvSpPr>
-        <p:spPr>
-          <a:xfrm>
-            <a:off x="640080" y="1463040"/>
-            <a:ext cx="3108960" cy="1371600"/>
-          </a:xfrm>
-          <a:prstGeom prst="rect">
-            <a:avLst/>
-          </a:prstGeom>
-          <a:noFill/>
-          <a:ln/>
-        </p:spPr>
-        <p:txBody>
-          <a:bodyPr wrap="square" lIns="0" tIns="0" rIns="0" bIns="0" rtlCol="0" anchor="ctr"/>
-          <a:lstStyle/>
-          <a:p>
-            <a:pPr marL="0" indent="0">
-              <a:buNone/>
-            </a:pPr>
-            <a:r>
-              <a:rPr lang="en-US" sz="1800" b="1" dirty="0">
-                <a:solidFill>
-                  <a:srgbClr val="1F1F1F"/>
-                </a:solidFill>
-                <a:latin typeface="Calibri" pitchFamily="34" charset="0"/>
-                <a:ea typeface="Calibri" pitchFamily="34" charset="-122"/>
-                <a:cs typeface="Calibri" pitchFamily="34" charset="-120"/>
-              </a:rPr>
-              <a:t>探究式學習</a:t>
-            </a:r>
-            <a:endParaRPr lang="en-US" sz="1600" dirty="0"/>
-          </a:p>
-          <a:p>
-            <a:pPr marL="0" indent="0">
-              <a:buNone/>
-            </a:pPr>
-            <a:r>
-              <a:rPr lang="en-US" sz="1800" b="1" dirty="0">
-                <a:solidFill>
-                  <a:srgbClr val="1F1F1F"/>
-                </a:solidFill>
-                <a:latin typeface="Calibri" pitchFamily="34" charset="0"/>
-                <a:ea typeface="Calibri" pitchFamily="34" charset="-122"/>
-                <a:cs typeface="Calibri" pitchFamily="34" charset="-120"/>
-              </a:rPr>
-              <a:t>Inquiry-Based Learning</a:t>
-            </a:r>
-            <a:endParaRPr lang="en-US" sz="1600" dirty="0"/>
-          </a:p>
-        </p:txBody>
-      </p:sp>
-      <p:sp>
-        <p:nvSpPr>
-          <p:cNvPr id="9" name="Shape 7"/>
-          <p:cNvSpPr/>
-          <p:nvPr/>
-        </p:nvSpPr>
-        <p:spPr>
-          <a:xfrm>
-            <a:off x="4251960" y="1005840"/>
-            <a:ext cx="3474720" cy="2011680"/>
-          </a:xfrm>
-          <a:prstGeom prst="rect">
-            <a:avLst/>
-          </a:prstGeom>
-          <a:solidFill>
-            <a:srgbClr val="21295C"/>
-          </a:solidFill>
-          <a:ln w="25400">
-            <a:solidFill>
-              <a:srgbClr val="E53935"/>
-            </a:solidFill>
-            <a:prstDash val="dash"/>
-          </a:ln>
-        </p:spPr>
-        <p:txBody>
-          <a:bodyPr/>
-          <a:p/>
-        </p:txBody>
-      </p:sp>
-      <p:sp>
-        <p:nvSpPr>
-          <p:cNvPr id="10" name="Text 8"/>
-          <p:cNvSpPr txBox="1"/>
-          <p:nvPr/>
-        </p:nvSpPr>
-        <p:spPr>
-          <a:xfrm>
-            <a:off x="4434840" y="1463040"/>
-            <a:ext cx="3108960" cy="1371600"/>
-          </a:xfrm>
-          <a:prstGeom prst="rect">
-            <a:avLst/>
-          </a:prstGeom>
-          <a:noFill/>
-          <a:ln/>
-        </p:spPr>
-        <p:txBody>
-          <a:bodyPr wrap="square" lIns="0" tIns="0" rIns="0" bIns="0" rtlCol="0" anchor="ctr"/>
-          <a:lstStyle/>
-          <a:p>
-            <a:pPr marL="0" indent="0">
-              <a:buNone/>
-            </a:pPr>
-            <a:r>
-              <a:rPr lang="en-US" sz="1800" b="1" dirty="0">
-                <a:solidFill>
-                  <a:srgbClr val="FFFFFF"/>
-                </a:solidFill>
-                <a:latin typeface="Calibri" pitchFamily="34" charset="0"/>
-                <a:ea typeface="Calibri" pitchFamily="34" charset="-122"/>
-                <a:cs typeface="Calibri" pitchFamily="34" charset="-120"/>
-              </a:rPr>
-              <a:t>氣候變遷教育</a:t>
-            </a:r>
-            <a:endParaRPr lang="en-US" sz="1600" dirty="0"/>
-          </a:p>
-          <a:p>
-            <a:pPr marL="0" indent="0">
-              <a:buNone/>
-            </a:pPr>
-            <a:r>
-              <a:rPr lang="en-US" sz="1800" b="1" dirty="0">
-                <a:solidFill>
-                  <a:srgbClr val="FFFFFF"/>
-                </a:solidFill>
-                <a:latin typeface="Calibri" pitchFamily="34" charset="0"/>
-                <a:ea typeface="Calibri" pitchFamily="34" charset="-122"/>
-                <a:cs typeface="Calibri" pitchFamily="34" charset="-120"/>
-              </a:rPr>
-              <a:t>Climate Change Education</a:t>
-            </a:r>
-            <a:endParaRPr lang="en-US" sz="1600" dirty="0"/>
-          </a:p>
-        </p:txBody>
-      </p:sp>
-      <p:sp>
-        <p:nvSpPr>
-          <p:cNvPr id="13" name="Shape 11"/>
-          <p:cNvSpPr/>
-          <p:nvPr/>
-        </p:nvSpPr>
-        <p:spPr>
-          <a:xfrm>
-            <a:off x="8046720" y="1005840"/>
-            <a:ext cx="3474720" cy="2011680"/>
-          </a:xfrm>
-          <a:prstGeom prst="rect">
-            <a:avLst/>
-          </a:prstGeom>
-          <a:solidFill>
-            <a:srgbClr val="EAF4FB"/>
-          </a:solidFill>
-          <a:ln w="25400">
-            <a:solidFill>
-              <a:srgbClr val="E53935"/>
-            </a:solidFill>
-            <a:prstDash val="dash"/>
-          </a:ln>
-        </p:spPr>
-        <p:txBody>
-          <a:bodyPr/>
-          <a:p/>
-        </p:txBody>
-      </p:sp>
-      <p:sp>
-        <p:nvSpPr>
-          <p:cNvPr id="14" name="Text 12"/>
-          <p:cNvSpPr txBox="1"/>
-          <p:nvPr/>
-        </p:nvSpPr>
-        <p:spPr>
-          <a:xfrm>
-            <a:off x="8229600" y="1463040"/>
-            <a:ext cx="3108960" cy="1371600"/>
-          </a:xfrm>
-          <a:prstGeom prst="rect">
-            <a:avLst/>
-          </a:prstGeom>
-          <a:noFill/>
-          <a:ln/>
-        </p:spPr>
-        <p:txBody>
-          <a:bodyPr wrap="square" lIns="0" tIns="0" rIns="0" bIns="0" rtlCol="0" anchor="ctr"/>
-          <a:lstStyle/>
-          <a:p>
-            <a:pPr marL="0" indent="0">
-              <a:buNone/>
-            </a:pPr>
-            <a:r>
-              <a:rPr lang="en-US" sz="1800" b="1" dirty="0">
-                <a:solidFill>
-                  <a:srgbClr val="1F1F1F"/>
-                </a:solidFill>
-                <a:latin typeface="Calibri" pitchFamily="34" charset="0"/>
-                <a:ea typeface="Calibri" pitchFamily="34" charset="-122"/>
-                <a:cs typeface="Calibri" pitchFamily="34" charset="-120"/>
-              </a:rPr>
-              <a:t>AI輔助適性學習系統</a:t>
-            </a:r>
-            <a:endParaRPr lang="en-US" sz="1600" dirty="0"/>
-          </a:p>
-          <a:p>
-            <a:pPr marL="0" indent="0">
-              <a:buNone/>
-            </a:pPr>
-            <a:r>
-              <a:rPr lang="en-US" sz="1800" b="1" dirty="0">
-                <a:solidFill>
-                  <a:srgbClr val="1F1F1F"/>
-                </a:solidFill>
-                <a:latin typeface="Calibri" pitchFamily="34" charset="0"/>
-                <a:ea typeface="Calibri" pitchFamily="34" charset="-122"/>
-                <a:cs typeface="Calibri" pitchFamily="34" charset="-120"/>
-              </a:rPr>
-              <a:t>Adaptive Learning System</a:t>
-            </a:r>
-            <a:endParaRPr lang="en-US" sz="1600" dirty="0"/>
-          </a:p>
-        </p:txBody>
-      </p:sp>
-      <p:sp>
-        <p:nvSpPr>
-          <p:cNvPr id="17" name="Shape 15"/>
-          <p:cNvSpPr/>
-          <p:nvPr/>
-        </p:nvSpPr>
-        <p:spPr>
-          <a:xfrm>
-            <a:off x="457200" y="3383280"/>
-            <a:ext cx="3474720" cy="2011680"/>
-          </a:xfrm>
-          <a:prstGeom prst="rect">
-            <a:avLst/>
-          </a:prstGeom>
-          <a:solidFill>
-            <a:srgbClr val="FFFFFF"/>
-          </a:solidFill>
-          <a:ln w="25400">
-            <a:solidFill>
-              <a:srgbClr val="E53935"/>
-            </a:solidFill>
-            <a:prstDash val="dash"/>
-          </a:ln>
-        </p:spPr>
-        <p:txBody>
-          <a:bodyPr/>
-          <a:p/>
-        </p:txBody>
-      </p:sp>
-      <p:sp>
-        <p:nvSpPr>
-          <p:cNvPr id="18" name="Text 16"/>
-          <p:cNvSpPr txBox="1"/>
-          <p:nvPr/>
-        </p:nvSpPr>
-        <p:spPr>
-          <a:xfrm>
-            <a:off x="640080" y="3840480"/>
-            <a:ext cx="3108960" cy="1371600"/>
-          </a:xfrm>
-          <a:prstGeom prst="rect">
-            <a:avLst/>
-          </a:prstGeom>
-          <a:noFill/>
-          <a:ln/>
-        </p:spPr>
-        <p:txBody>
-          <a:bodyPr wrap="square" lIns="0" tIns="0" rIns="0" bIns="0" rtlCol="0" anchor="ctr"/>
-          <a:lstStyle/>
-          <a:p>
-            <a:pPr marL="0" indent="0">
-              <a:buNone/>
-            </a:pPr>
-            <a:r>
-              <a:rPr lang="en-US" sz="1800" b="1" dirty="0">
-                <a:solidFill>
-                  <a:srgbClr val="1F1F1F"/>
-                </a:solidFill>
-                <a:latin typeface="Calibri" pitchFamily="34" charset="0"/>
-                <a:ea typeface="Calibri" pitchFamily="34" charset="-122"/>
-                <a:cs typeface="Calibri" pitchFamily="34" charset="-120"/>
-              </a:rPr>
-              <a:t>隱形文字</a:t>
-            </a:r>
-            <a:endParaRPr lang="en-US" sz="1600" dirty="0"/>
-          </a:p>
-          <a:p>
-            <a:pPr marL="0" indent="0">
-              <a:buNone/>
-            </a:pPr>
-            <a:r>
-              <a:rPr lang="en-US" sz="1800" b="1" dirty="0">
-                <a:solidFill>
-                  <a:srgbClr val="1F1F1F"/>
-                </a:solidFill>
-                <a:latin typeface="Calibri" pitchFamily="34" charset="0"/>
-                <a:ea typeface="Calibri" pitchFamily="34" charset="-122"/>
-                <a:cs typeface="Calibri" pitchFamily="34" charset="-120"/>
-              </a:rPr>
-              <a:t>Hidden Text (白字白底)</a:t>
-            </a:r>
-            <a:endParaRPr lang="en-US" sz="1600" dirty="0"/>
-          </a:p>
-        </p:txBody>
-      </p:sp>
-      <p:sp>
-        <p:nvSpPr>
-          <p:cNvPr id="21" name="Shape 19"/>
-          <p:cNvSpPr/>
-          <p:nvPr/>
-        </p:nvSpPr>
-        <p:spPr>
-          <a:xfrm>
-            <a:off x="4251960" y="3383280"/>
-            <a:ext cx="3474720" cy="2011680"/>
-          </a:xfrm>
-          <a:prstGeom prst="rect">
-            <a:avLst/>
-          </a:prstGeom>
-          <a:solidFill>
-            <a:srgbClr val="F4F8FA"/>
           </a:solidFill>
           <a:ln w="12700">
             <a:solidFill>
@@ -3681,13 +3827,13 @@
       </p:sp>
       <p:sp>
         <p:nvSpPr>
-          <p:cNvPr id="22" name="Text 20"/>
-          <p:cNvSpPr txBox="1"/>
-          <p:nvPr/>
-        </p:nvSpPr>
-        <p:spPr>
-          <a:xfrm>
-            <a:off x="4434840" y="3840480"/>
+          <p:cNvPr id="6" name="Text 4"/>
+          <p:cNvSpPr txBox="1"/>
+          <p:nvPr/>
+        </p:nvSpPr>
+        <p:spPr>
+          <a:xfrm>
+            <a:off x="640080" y="1463040"/>
             <a:ext cx="3108960" cy="1371600"/>
           </a:xfrm>
           <a:prstGeom prst="rect">
@@ -3737,13 +3883,13 @@
       </p:sp>
       <p:sp>
         <p:nvSpPr>
-          <p:cNvPr id="24" name="Shape 22"/>
+          <p:cNvPr id="9" name="Shape 7"/>
           <p:cNvSpPr/>
           <p:nvPr/>
         </p:nvSpPr>
         <p:spPr>
           <a:xfrm>
-            <a:off x="8046720" y="3383280"/>
+            <a:off x="4251960" y="1005840"/>
             <a:ext cx="3474720" cy="2011680"/>
           </a:xfrm>
           <a:prstGeom prst="rect">
@@ -3766,6 +3912,346 @@
       </p:sp>
       <p:sp>
         <p:nvSpPr>
+          <p:cNvPr id="10" name="Text 8"/>
+          <p:cNvSpPr txBox="1"/>
+          <p:nvPr/>
+        </p:nvSpPr>
+        <p:spPr>
+          <a:xfrm>
+            <a:off x="4434840" y="1463040"/>
+            <a:ext cx="3108960" cy="1371600"/>
+          </a:xfrm>
+          <a:prstGeom prst="rect">
+            <a:avLst/>
+          </a:prstGeom>
+          <a:noFill/>
+          <a:ln/>
+        </p:spPr>
+        <p:txBody>
+          <a:bodyPr wrap="square" lIns="0" tIns="0" rIns="0" bIns="0" rtlCol="0" anchor="ctr"/>
+          <a:lstStyle/>
+          <a:p>
+            <a:pPr marL="0" indent="0">
+              <a:buNone/>
+            </a:pPr>
+            <a:r>
+              <a:rPr lang="en-US" sz="1800" b="1" dirty="0">
+                <a:solidFill>
+                  <a:srgbClr val="FFFFFF"/>
+                </a:solidFill>
+                <a:latin typeface="Calibri" pitchFamily="34" charset="0"/>
+                <a:ea typeface="Calibri" pitchFamily="34" charset="-122"/>
+                <a:cs typeface="Calibri" pitchFamily="34" charset="-120"/>
+              </a:rPr>
+              <a:t>氣候變遷教育</a:t>
+            </a:r>
+            <a:endParaRPr lang="en-US" sz="1600" dirty="0"/>
+          </a:p>
+          <a:p>
+            <a:pPr marL="0" indent="0">
+              <a:buNone/>
+            </a:pPr>
+            <a:r>
+              <a:rPr lang="en-US" sz="1800" b="1" dirty="0">
+                <a:solidFill>
+                  <a:srgbClr val="FFFFFF"/>
+                </a:solidFill>
+                <a:latin typeface="Calibri" pitchFamily="34" charset="0"/>
+                <a:ea typeface="Calibri" pitchFamily="34" charset="-122"/>
+                <a:cs typeface="Calibri" pitchFamily="34" charset="-120"/>
+              </a:rPr>
+              <a:t>Climate Change Education</a:t>
+            </a:r>
+            <a:endParaRPr lang="en-US" sz="1600" dirty="0"/>
+          </a:p>
+        </p:txBody>
+      </p:sp>
+      <p:sp>
+        <p:nvSpPr>
+          <p:cNvPr id="13" name="Shape 11"/>
+          <p:cNvSpPr/>
+          <p:nvPr/>
+        </p:nvSpPr>
+        <p:spPr>
+          <a:xfrm>
+            <a:off x="8046720" y="1005840"/>
+            <a:ext cx="3474720" cy="2011680"/>
+          </a:xfrm>
+          <a:prstGeom prst="rect">
+            <a:avLst/>
+          </a:prstGeom>
+          <a:solidFill>
+            <a:srgbClr val="EAF4FB"/>
+          </a:solidFill>
+          <a:ln w="12700">
+            <a:solidFill>
+              <a:srgbClr val="2E7D32"/>
+            </a:solidFill>
+            <a:prstDash val="solid"/>
+          </a:ln>
+        </p:spPr>
+        <p:txBody>
+          <a:bodyPr/>
+          <a:p/>
+        </p:txBody>
+      </p:sp>
+      <p:sp>
+        <p:nvSpPr>
+          <p:cNvPr id="14" name="Text 12"/>
+          <p:cNvSpPr txBox="1"/>
+          <p:nvPr/>
+        </p:nvSpPr>
+        <p:spPr>
+          <a:xfrm>
+            <a:off x="8229600" y="1463040"/>
+            <a:ext cx="3108960" cy="1371600"/>
+          </a:xfrm>
+          <a:prstGeom prst="rect">
+            <a:avLst/>
+          </a:prstGeom>
+          <a:noFill/>
+          <a:ln/>
+        </p:spPr>
+        <p:txBody>
+          <a:bodyPr wrap="square" lIns="0" tIns="0" rIns="0" bIns="0" rtlCol="0" anchor="ctr"/>
+          <a:lstStyle/>
+          <a:p>
+            <a:pPr marL="0" indent="0">
+              <a:buNone/>
+            </a:pPr>
+            <a:r>
+              <a:rPr lang="en-US" sz="1800" b="1" dirty="0">
+                <a:solidFill>
+                  <a:srgbClr val="1B2430"/>
+                </a:solidFill>
+                <a:latin typeface="Calibri" pitchFamily="34" charset="0"/>
+                <a:ea typeface="Calibri" pitchFamily="34" charset="-122"/>
+                <a:cs typeface="Calibri" pitchFamily="34" charset="-120"/>
+              </a:rPr>
+              <a:t>AI輔助適性學習系統</a:t>
+            </a:r>
+            <a:endParaRPr lang="en-US" sz="1600" dirty="0"/>
+          </a:p>
+          <a:p>
+            <a:pPr marL="0" indent="0">
+              <a:buNone/>
+            </a:pPr>
+            <a:r>
+              <a:rPr lang="en-US" sz="1800" b="1" dirty="0">
+                <a:solidFill>
+                  <a:srgbClr val="1B2430"/>
+                </a:solidFill>
+                <a:latin typeface="Calibri" pitchFamily="34" charset="0"/>
+                <a:ea typeface="Calibri" pitchFamily="34" charset="-122"/>
+                <a:cs typeface="Calibri" pitchFamily="34" charset="-120"/>
+              </a:rPr>
+              <a:t>Adaptive Learning System</a:t>
+            </a:r>
+            <a:endParaRPr lang="en-US" sz="1600" dirty="0"/>
+          </a:p>
+        </p:txBody>
+      </p:sp>
+      <p:sp>
+        <p:nvSpPr>
+          <p:cNvPr id="17" name="Shape 15"/>
+          <p:cNvSpPr/>
+          <p:nvPr/>
+        </p:nvSpPr>
+        <p:spPr>
+          <a:xfrm>
+            <a:off x="457200" y="3383280"/>
+            <a:ext cx="3474720" cy="2011680"/>
+          </a:xfrm>
+          <a:prstGeom prst="rect">
+            <a:avLst/>
+          </a:prstGeom>
+          <a:solidFill>
+            <a:srgbClr val="FFFFFF"/>
+          </a:solidFill>
+          <a:ln w="12700">
+            <a:solidFill>
+              <a:srgbClr val="2E7D32"/>
+            </a:solidFill>
+            <a:prstDash val="solid"/>
+          </a:ln>
+        </p:spPr>
+        <p:txBody>
+          <a:bodyPr/>
+          <a:p/>
+        </p:txBody>
+      </p:sp>
+      <p:sp>
+        <p:nvSpPr>
+          <p:cNvPr id="18" name="Text 16"/>
+          <p:cNvSpPr txBox="1"/>
+          <p:nvPr/>
+        </p:nvSpPr>
+        <p:spPr>
+          <a:xfrm>
+            <a:off x="640080" y="3840480"/>
+            <a:ext cx="3108960" cy="1371600"/>
+          </a:xfrm>
+          <a:prstGeom prst="rect">
+            <a:avLst/>
+          </a:prstGeom>
+          <a:noFill/>
+          <a:ln/>
+        </p:spPr>
+        <p:txBody>
+          <a:bodyPr wrap="square" lIns="0" tIns="0" rIns="0" bIns="0" rtlCol="0" anchor="ctr"/>
+          <a:lstStyle/>
+          <a:p>
+            <a:pPr marL="0" indent="0">
+              <a:buNone/>
+            </a:pPr>
+            <a:r>
+              <a:rPr lang="en-US" sz="1800" b="1" dirty="0">
+                <a:solidFill>
+                  <a:srgbClr val="1B2430"/>
+                </a:solidFill>
+                <a:latin typeface="Calibri" pitchFamily="34" charset="0"/>
+                <a:ea typeface="Calibri" pitchFamily="34" charset="-122"/>
+                <a:cs typeface="Calibri" pitchFamily="34" charset="-120"/>
+              </a:rPr>
+              <a:t>高對比文字</a:t>
+            </a:r>
+            <a:endParaRPr lang="en-US" sz="1600" dirty="0"/>
+          </a:p>
+          <a:p>
+            <a:pPr marL="0" indent="0">
+              <a:buNone/>
+            </a:pPr>
+            <a:r>
+              <a:rPr lang="en-US" sz="1800" b="1" dirty="0">
+                <a:solidFill>
+                  <a:srgbClr val="1B2430"/>
+                </a:solidFill>
+                <a:latin typeface="Calibri" pitchFamily="34" charset="0"/>
+                <a:ea typeface="Calibri" pitchFamily="34" charset="-122"/>
+                <a:cs typeface="Calibri" pitchFamily="34" charset="-120"/>
+              </a:rPr>
+              <a:t>High Contrast Text</a:t>
+            </a:r>
+            <a:endParaRPr lang="en-US" sz="1600" dirty="0"/>
+          </a:p>
+        </p:txBody>
+      </p:sp>
+      <p:sp>
+        <p:nvSpPr>
+          <p:cNvPr id="21" name="Shape 19"/>
+          <p:cNvSpPr/>
+          <p:nvPr/>
+        </p:nvSpPr>
+        <p:spPr>
+          <a:xfrm>
+            <a:off x="4251960" y="3383280"/>
+            <a:ext cx="3474720" cy="2011680"/>
+          </a:xfrm>
+          <a:prstGeom prst="rect">
+            <a:avLst/>
+          </a:prstGeom>
+          <a:solidFill>
+            <a:srgbClr val="F4F8FA"/>
+          </a:solidFill>
+          <a:ln w="12700">
+            <a:solidFill>
+              <a:srgbClr val="2E7D32"/>
+            </a:solidFill>
+            <a:prstDash val="solid"/>
+          </a:ln>
+        </p:spPr>
+        <p:txBody>
+          <a:bodyPr/>
+          <a:p/>
+        </p:txBody>
+      </p:sp>
+      <p:sp>
+        <p:nvSpPr>
+          <p:cNvPr id="22" name="Text 20"/>
+          <p:cNvSpPr txBox="1"/>
+          <p:nvPr/>
+        </p:nvSpPr>
+        <p:spPr>
+          <a:xfrm>
+            <a:off x="4434840" y="3840480"/>
+            <a:ext cx="3108960" cy="1371600"/>
+          </a:xfrm>
+          <a:prstGeom prst="rect">
+            <a:avLst/>
+          </a:prstGeom>
+          <a:noFill/>
+          <a:ln/>
+        </p:spPr>
+        <p:txBody>
+          <a:bodyPr wrap="square" lIns="0" tIns="0" rIns="0" bIns="0" rtlCol="0" anchor="ctr"/>
+          <a:lstStyle/>
+          <a:p>
+            <a:pPr marL="0" indent="0">
+              <a:buNone/>
+            </a:pPr>
+            <a:r>
+              <a:rPr lang="en-US" sz="1800" b="1" dirty="0">
+                <a:solidFill>
+                  <a:srgbClr val="1B2430"/>
+                </a:solidFill>
+                <a:latin typeface="Calibri" pitchFamily="34" charset="0"/>
+                <a:ea typeface="Calibri" pitchFamily="34" charset="-122"/>
+                <a:cs typeface="Calibri" pitchFamily="34" charset="-120"/>
+              </a:rPr>
+              <a:t>探究式學習</a:t>
+            </a:r>
+            <a:endParaRPr lang="en-US" sz="1600" dirty="0"/>
+          </a:p>
+          <a:p>
+            <a:pPr marL="0" indent="0">
+              <a:buNone/>
+            </a:pPr>
+            <a:r>
+              <a:rPr lang="en-US" sz="1800" b="1" dirty="0">
+                <a:solidFill>
+                  <a:srgbClr val="1B2430"/>
+                </a:solidFill>
+                <a:latin typeface="Calibri" pitchFamily="34" charset="0"/>
+                <a:ea typeface="Calibri" pitchFamily="34" charset="-122"/>
+                <a:cs typeface="Calibri" pitchFamily="34" charset="-120"/>
+              </a:rPr>
+              <a:t>Inquiry-Based Learning</a:t>
+            </a:r>
+            <a:endParaRPr lang="en-US" sz="1600" dirty="0"/>
+          </a:p>
+        </p:txBody>
+      </p:sp>
+      <p:sp>
+        <p:nvSpPr>
+          <p:cNvPr id="24" name="Shape 22"/>
+          <p:cNvSpPr/>
+          <p:nvPr/>
+        </p:nvSpPr>
+        <p:spPr>
+          <a:xfrm>
+            <a:off x="8046720" y="3383280"/>
+            <a:ext cx="3474720" cy="2011680"/>
+          </a:xfrm>
+          <a:prstGeom prst="rect">
+            <a:avLst/>
+          </a:prstGeom>
+          <a:solidFill>
+            <a:srgbClr val="21295C"/>
+          </a:solidFill>
+          <a:ln w="12700">
+            <a:solidFill>
+              <a:srgbClr val="2E7D32"/>
+            </a:solidFill>
+            <a:prstDash val="solid"/>
+          </a:ln>
+        </p:spPr>
+        <p:txBody>
+          <a:bodyPr/>
+          <a:p/>
+        </p:txBody>
+      </p:sp>
+      <p:sp>
+        <p:nvSpPr>
           <p:cNvPr id="25" name="Text 23"/>
           <p:cNvSpPr txBox="1"/>
           <p:nvPr/>
@@ -3846,169 +4332,11 @@
             <a:r>
               <a:rPr sz="1800">
                 <a:solidFill>
-                  <a:srgbClr val="1F1F1F"/>
-                </a:solidFill>
+                  <a:srgbClr val="5A6B78"/>
+                </a:solidFill>
+                <a:latin typeface="Calibri"/>
               </a:rPr>
               <a:t>6</a:t>
-            </a:r>
-          </a:p>
-        </p:txBody>
-      </p:sp>
-    </p:spTree>
-  </p:cSld>
-  <p:clrMapOvr>
-    <a:masterClrMapping/>
-  </p:clrMapOvr>
-</p:sld>
-</file>
-
-<file path=ppt/slides/slide6.xml><?xml version="1.0" encoding="utf-8"?>
-<p:sld xmlns:a="http://schemas.openxmlformats.org/drawingml/2006/main" xmlns:p="http://schemas.openxmlformats.org/presentationml/2006/main" xmlns:r="http://schemas.openxmlformats.org/officeDocument/2006/relationships">
-  <p:cSld>
-    <p:spTree>
-      <p:nvGrpSpPr>
-        <p:cNvPr id="1" name=""/>
-        <p:cNvGrpSpPr/>
-        <p:nvPr/>
-      </p:nvGrpSpPr>
-      <p:grpSpPr/>
-      <p:sp>
-        <p:nvSpPr>
-          <p:cNvPr id="2" name="Shape 0"/>
-          <p:cNvSpPr/>
-          <p:nvPr/>
-        </p:nvSpPr>
-        <p:spPr>
-          <a:xfrm>
-            <a:off x="0" y="0"/>
-            <a:ext cx="12188952" cy="6858000"/>
-          </a:xfrm>
-          <a:prstGeom prst="rect">
-            <a:avLst/>
-          </a:prstGeom>
-          <a:solidFill>
-            <a:srgbClr val="FFFFFF"/>
-          </a:solidFill>
-          <a:ln/>
-        </p:spPr>
-        <p:txBody>
-          <a:bodyPr/>
-          <a:p/>
-        </p:txBody>
-      </p:sp>
-      <p:sp>
-        <p:nvSpPr>
-          <p:cNvPr id="3" name="TextBox 2"/>
-          <p:cNvSpPr txBox="1"/>
-          <p:nvPr/>
-        </p:nvSpPr>
-        <p:spPr>
-          <a:xfrm>
-            <a:off x="914400" y="1828800"/>
-            <a:ext cx="10363200" cy="3200400"/>
-          </a:xfrm>
-          <a:prstGeom prst="rect">
-            <a:avLst/>
-          </a:prstGeom>
-          <a:noFill/>
-        </p:spPr>
-        <p:txBody>
-          <a:bodyPr wrap="square">
-            <a:spAutoFit/>
-          </a:bodyPr>
-          <a:lstStyle/>
-          <a:p>
-            <a:pPr algn="ctr">
-              <a:spcAft>
-                <a:spcPts val="1200"/>
-              </a:spcAft>
-            </a:pPr>
-            <a:r>
-              <a:rPr sz="3600" b="1">
-                <a:solidFill>
-                  <a:srgbClr val="1F1F1F"/>
-                </a:solidFill>
-              </a:rPr>
-              <a:t>1151科學教育與傳播的未來： AI理論與實踐</a:t>
-            </a:r>
-          </a:p>
-          <a:p>
-            <a:pPr algn="ctr">
-              <a:spcAft>
-                <a:spcPts val="1200"/>
-              </a:spcAft>
-            </a:pPr>
-            <a:r>
-              <a:rPr sz="2800" b="0">
-                <a:solidFill>
-                  <a:srgbClr val="1F1F1F"/>
-                </a:solidFill>
-              </a:rPr>
-              <a:t>隨堂測驗1 instruction in class exam</a:t>
-            </a:r>
-          </a:p>
-          <a:p>
-            <a:pPr algn="ctr">
-              <a:spcAft>
-                <a:spcPts val="1200"/>
-              </a:spcAft>
-            </a:pPr>
-            <a:r>
-              <a:rPr sz="2400" b="0">
-                <a:solidFill>
-                  <a:srgbClr val="1F1F1F"/>
-                </a:solidFill>
-              </a:rPr>
-              <a:t>學號：41411005E</a:t>
-            </a:r>
-          </a:p>
-          <a:p>
-            <a:pPr algn="ctr">
-              <a:spcAft>
-                <a:spcPts val="1200"/>
-              </a:spcAft>
-            </a:pPr>
-            <a:r>
-              <a:rPr sz="2400" b="0">
-                <a:solidFill>
-                  <a:srgbClr val="1F1F1F"/>
-                </a:solidFill>
-              </a:rPr>
-              <a:t>姓名：林俊緯</a:t>
-            </a:r>
-          </a:p>
-        </p:txBody>
-      </p:sp>
-      <p:sp>
-        <p:nvSpPr>
-          <p:cNvPr id="4" name="TextBox 3"/>
-          <p:cNvSpPr txBox="1"/>
-          <p:nvPr/>
-        </p:nvSpPr>
-        <p:spPr>
-          <a:xfrm>
-            <a:off x="10911840" y="6263640"/>
-            <a:ext cx="914400" cy="411480"/>
-          </a:xfrm>
-          <a:prstGeom prst="rect">
-            <a:avLst/>
-          </a:prstGeom>
-          <a:noFill/>
-        </p:spPr>
-        <p:txBody>
-          <a:bodyPr wrap="none">
-            <a:spAutoFit/>
-          </a:bodyPr>
-          <a:lstStyle/>
-          <a:p>
-            <a:pPr algn="r"/>
-            <a:r>
-              <a:rPr sz="1800">
-                <a:solidFill>
-                  <a:srgbClr val="1F1F1F"/>
-                </a:solidFill>
-              </a:rPr>
-              <a:t>1</a:t>
             </a:r>
           </a:p>
         </p:txBody>

</xml_diff>